<commit_message>
WIP: slide 12 equation table, massreg resource fix, sweep instructions
Slide 12 moves the evaluated combinatorics out of the equation line into a
T / H_T / T! table. The middot separating the values read as multiplication
against the same glyph used inside the denominator.

massreg job requests the typed nvidia.com/a100 resource; a generic
nvidia.com/gpu request can never schedule on an A100 node.

Co-Authored-By: Claude Opus 5 <noreply@anthropic.com>
</commit_message>
<xml_diff>
--- a/reports/slides/working_meeting_2026-08-13.pptx
+++ b/reports/slides/working_meeting_2026-08-13.pptx
@@ -5582,25 +5582,34 @@
                 </a:solidFill>
                 <a:latin typeface="Georgia"/>
               </a:rPr>
-              <a:t>! ]   →   </a:t>
-            </a:r>
-            <a:r>
-              <a:rPr sz="1900" b="1" i="0">
-                <a:solidFill>
-                  <a:srgbClr val="00629B"/>
+              <a:t>! ]    assignments for </a:t>
+            </a:r>
+            <a:r>
+              <a:rPr sz="1900" b="0" i="1">
+                <a:solidFill>
+                  <a:srgbClr val="182B49"/>
                 </a:solidFill>
                 <a:latin typeface="Georgia"/>
               </a:rPr>
-              <a:t>1.9×10</a:t>
-            </a:r>
-            <a:r>
-              <a:rPr sz="1178" b="1" i="0" baseline="30000">
-                <a:solidFill>
-                  <a:srgbClr val="00629B"/>
+              <a:t>T</a:t>
+            </a:r>
+            <a:r>
+              <a:rPr sz="1900" b="0" i="0">
+                <a:solidFill>
+                  <a:srgbClr val="182B49"/>
                 </a:solidFill>
                 <a:latin typeface="Georgia"/>
               </a:rPr>
-              <a:t>4</a:t>
+              <a:t> tops in </a:t>
+            </a:r>
+            <a:r>
+              <a:rPr sz="1900" b="0" i="1">
+                <a:solidFill>
+                  <a:srgbClr val="182B49"/>
+                </a:solidFill>
+                <a:latin typeface="Georgia"/>
+              </a:rPr>
+              <a:t>N</a:t>
             </a:r>
             <a:r>
               <a:rPr sz="1900" b="0" i="0">
@@ -5609,34 +5618,7 @@
                 </a:solidFill>
                 <a:latin typeface="Georgia"/>
               </a:rPr>
-              <a:t> (t̄t)  ·  </a:t>
-            </a:r>
-            <a:r>
-              <a:rPr sz="1900" b="1" i="0">
-                <a:solidFill>
-                  <a:srgbClr val="00629B"/>
-                </a:solidFill>
-                <a:latin typeface="Georgia"/>
-              </a:rPr>
-              <a:t>2.3×10</a:t>
-            </a:r>
-            <a:r>
-              <a:rPr sz="1178" b="1" i="0" baseline="30000">
-                <a:solidFill>
-                  <a:srgbClr val="00629B"/>
-                </a:solidFill>
-                <a:latin typeface="Georgia"/>
-              </a:rPr>
-              <a:t>9</a:t>
-            </a:r>
-            <a:r>
-              <a:rPr sz="1900" b="0" i="0">
-                <a:solidFill>
-                  <a:srgbClr val="182B49"/>
-                </a:solidFill>
-                <a:latin typeface="Georgia"/>
-              </a:rPr>
-              <a:t> (tttt)</a:t>
+              <a:t> jets</a:t>
             </a:r>
           </a:p>
         </p:txBody>
@@ -5650,13 +5632,13 @@
         <p:spPr>
           <a:xfrm>
             <a:off x="685800" y="3467100"/>
-            <a:ext cx="10820400" cy="514350"/>
+            <a:ext cx="10820400" cy="1371600"/>
           </a:xfrm>
           <a:prstGeom prst="rect">
             <a:avLst/>
           </a:prstGeom>
           <a:solidFill>
-            <a:srgbClr val="F4F6F8"/>
+            <a:srgbClr val="EEF4F9"/>
           </a:solidFill>
           <a:ln>
             <a:noFill/>
@@ -5687,14 +5669,58 @@
       </p:sp>
       <p:sp>
         <p:nvSpPr>
-          <p:cNvPr id="13" name="TextBox 12"/>
+          <p:cNvPr id="13" name="Rectangle 12"/>
+          <p:cNvSpPr/>
+          <p:nvPr/>
+        </p:nvSpPr>
+        <p:spPr>
+          <a:xfrm>
+            <a:off x="685800" y="3467100"/>
+            <a:ext cx="47625" cy="1371600"/>
+          </a:xfrm>
+          <a:prstGeom prst="rect">
+            <a:avLst/>
+          </a:prstGeom>
+          <a:solidFill>
+            <a:srgbClr val="00629B"/>
+          </a:solidFill>
+          <a:ln>
+            <a:noFill/>
+          </a:ln>
+          <a:effectLst/>
+        </p:spPr>
+        <p:style>
+          <a:lnRef idx="1">
+            <a:schemeClr val="accent1"/>
+          </a:lnRef>
+          <a:fillRef idx="3">
+            <a:schemeClr val="accent1"/>
+          </a:fillRef>
+          <a:effectRef idx="2">
+            <a:schemeClr val="accent1"/>
+          </a:effectRef>
+          <a:fontRef idx="minor">
+            <a:schemeClr val="lt1"/>
+          </a:fontRef>
+        </p:style>
+        <p:txBody>
+          <a:bodyPr rtlCol="0" anchor="ctr"/>
+          <a:lstStyle/>
+          <a:p>
+            <a:pPr algn="ctr"/>
+          </a:p>
+        </p:txBody>
+      </p:sp>
+      <p:sp>
+        <p:nvSpPr>
+          <p:cNvPr id="14" name="TextBox 13"/>
           <p:cNvSpPr txBox="1"/>
           <p:nvPr/>
         </p:nvSpPr>
         <p:spPr>
           <a:xfrm>
-            <a:off x="895350" y="3562350"/>
-            <a:ext cx="10401300" cy="381000"/>
+            <a:off x="895350" y="3543300"/>
+            <a:ext cx="10401300" cy="247650"/>
           </a:xfrm>
           <a:prstGeom prst="rect">
             <a:avLst/>
@@ -5707,91 +5733,450 @@
           </a:bodyPr>
           <a:lstStyle/>
           <a:p>
-            <a:pPr algn="ctr"/>
-            <a:r>
-              <a:rPr sz="1900" b="0" i="0">
-                <a:solidFill>
-                  <a:srgbClr val="182B49"/>
-                </a:solidFill>
-                <a:latin typeface="Georgia"/>
-              </a:rPr>
-              <a:t>label symmetry </a:t>
-            </a:r>
-            <a:r>
-              <a:rPr sz="1900" b="0" i="1">
-                <a:solidFill>
-                  <a:srgbClr val="182B49"/>
-                </a:solidFill>
-                <a:latin typeface="Georgia"/>
-              </a:rPr>
-              <a:t>T</a:t>
-            </a:r>
-            <a:r>
-              <a:rPr sz="1900" b="0" i="0">
-                <a:solidFill>
-                  <a:srgbClr val="182B49"/>
-                </a:solidFill>
-                <a:latin typeface="Georgia"/>
-              </a:rPr>
-              <a:t>! = </a:t>
-            </a:r>
-            <a:r>
-              <a:rPr sz="1900" b="1" i="0">
+            <a:r>
+              <a:rPr sz="1000" b="1" i="0">
                 <a:solidFill>
                   <a:srgbClr val="00629B"/>
                 </a:solidFill>
-                <a:latin typeface="Georgia"/>
-              </a:rPr>
-              <a:t>2</a:t>
-            </a:r>
-            <a:r>
-              <a:rPr sz="1900" b="0" i="0">
-                <a:solidFill>
-                  <a:srgbClr val="182B49"/>
-                </a:solidFill>
-                <a:latin typeface="Georgia"/>
-              </a:rPr>
-              <a:t> (t̄t)  ·  </a:t>
-            </a:r>
-            <a:r>
-              <a:rPr sz="1900" b="1" i="0">
-                <a:solidFill>
-                  <a:srgbClr val="00629B"/>
-                </a:solidFill>
-                <a:latin typeface="Georgia"/>
-              </a:rPr>
-              <a:t>24</a:t>
-            </a:r>
-            <a:r>
-              <a:rPr sz="1900" b="0" i="0">
-                <a:solidFill>
-                  <a:srgbClr val="182B49"/>
-                </a:solidFill>
-                <a:latin typeface="Georgia"/>
-              </a:rPr>
-              <a:t> (tttt)  ·  </a:t>
-            </a:r>
-            <a:r>
-              <a:rPr sz="1900" b="1" i="0">
-                <a:solidFill>
-                  <a:srgbClr val="00629B"/>
-                </a:solidFill>
-                <a:latin typeface="Georgia"/>
-              </a:rPr>
-              <a:t>720</a:t>
-            </a:r>
-            <a:r>
-              <a:rPr sz="1900" b="0" i="0">
-                <a:solidFill>
-                  <a:srgbClr val="182B49"/>
-                </a:solidFill>
-                <a:latin typeface="Georgia"/>
-              </a:rPr>
-              <a:t> (t̄tt̄tt̄t)</a:t>
-            </a:r>
-          </a:p>
-        </p:txBody>
-      </p:sp>
+                <a:latin typeface="Helvetica Neue"/>
+              </a:rPr>
+              <a:t>EVALUATED AT N = 3T + 4 JETS</a:t>
+            </a:r>
+          </a:p>
+        </p:txBody>
+      </p:sp>
+      <p:graphicFrame>
+        <p:nvGraphicFramePr>
+          <p:cNvPr id="15" name="Table 14"/>
+          <p:cNvGraphicFramePr>
+            <a:graphicFrameLocks noGrp="1"/>
+          </p:cNvGraphicFramePr>
+          <p:nvPr/>
+        </p:nvGraphicFramePr>
+        <p:xfrm>
+          <a:off x="895350" y="3771900"/>
+          <a:ext cx="10401300" cy="990600"/>
+        </p:xfrm>
+        <a:graphic>
+          <a:graphicData uri="http://schemas.openxmlformats.org/drawingml/2006/table">
+            <a:tbl>
+              <a:tblPr firstRow="1" bandRow="1">
+                <a:tableStyleId>{5C22544A-7EE6-4342-B048-85BDC9FD1C3A}</a:tableStyleId>
+              </a:tblPr>
+              <a:tblGrid>
+                <a:gridCol w="2600325"/>
+                <a:gridCol w="2600325"/>
+                <a:gridCol w="2600325"/>
+                <a:gridCol w="2600325"/>
+              </a:tblGrid>
+              <a:tr h="247650">
+                <a:tc>
+                  <a:txBody>
+                    <a:bodyPr/>
+                    <a:lstStyle/>
+                    <a:p/>
+                  </a:txBody>
+                  <a:tcPr anchor="ctr">
+                    <a:solidFill>
+                      <a:srgbClr val="F4F6F8"/>
+                    </a:solidFill>
+                  </a:tcPr>
+                </a:tc>
+                <a:tc>
+                  <a:txBody>
+                    <a:bodyPr/>
+                    <a:lstStyle/>
+                    <a:p>
+                      <a:r>
+                        <a:rPr sz="1100" b="1" i="1">
+                          <a:solidFill>
+                            <a:srgbClr val="00629B"/>
+                          </a:solidFill>
+                          <a:latin typeface="Georgia"/>
+                        </a:rPr>
+                        <a:t>T</a:t>
+                      </a:r>
+                    </a:p>
+                  </a:txBody>
+                  <a:tcPr anchor="ctr">
+                    <a:solidFill>
+                      <a:srgbClr val="F4F6F8"/>
+                    </a:solidFill>
+                  </a:tcPr>
+                </a:tc>
+                <a:tc>
+                  <a:txBody>
+                    <a:bodyPr/>
+                    <a:lstStyle/>
+                    <a:p>
+                      <a:r>
+                        <a:rPr sz="1100" b="1" i="1">
+                          <a:solidFill>
+                            <a:srgbClr val="00629B"/>
+                          </a:solidFill>
+                          <a:latin typeface="Georgia"/>
+                        </a:rPr>
+                        <a:t>H</a:t>
+                      </a:r>
+                      <a:r>
+                        <a:rPr sz="682" b="1" i="1" baseline="-25000">
+                          <a:solidFill>
+                            <a:srgbClr val="00629B"/>
+                          </a:solidFill>
+                          <a:latin typeface="Georgia"/>
+                        </a:rPr>
+                        <a:t>T</a:t>
+                      </a:r>
+                    </a:p>
+                  </a:txBody>
+                  <a:tcPr anchor="ctr">
+                    <a:solidFill>
+                      <a:srgbClr val="F4F6F8"/>
+                    </a:solidFill>
+                  </a:tcPr>
+                </a:tc>
+                <a:tc>
+                  <a:txBody>
+                    <a:bodyPr/>
+                    <a:lstStyle/>
+                    <a:p>
+                      <a:r>
+                        <a:rPr sz="1100" b="1" i="0">
+                          <a:solidFill>
+                            <a:srgbClr val="00629B"/>
+                          </a:solidFill>
+                          <a:latin typeface="Helvetica Neue"/>
+                        </a:rPr>
+                        <a:t>label symmetry </a:t>
+                      </a:r>
+                      <a:r>
+                        <a:rPr sz="1100" b="1" i="1">
+                          <a:solidFill>
+                            <a:srgbClr val="00629B"/>
+                          </a:solidFill>
+                          <a:latin typeface="Georgia"/>
+                        </a:rPr>
+                        <a:t>T</a:t>
+                      </a:r>
+                      <a:r>
+                        <a:rPr sz="1100" b="1" i="0">
+                          <a:solidFill>
+                            <a:srgbClr val="00629B"/>
+                          </a:solidFill>
+                          <a:latin typeface="Helvetica Neue"/>
+                        </a:rPr>
+                        <a:t>!</a:t>
+                      </a:r>
+                    </a:p>
+                  </a:txBody>
+                  <a:tcPr anchor="ctr">
+                    <a:solidFill>
+                      <a:srgbClr val="F4F6F8"/>
+                    </a:solidFill>
+                  </a:tcPr>
+                </a:tc>
+              </a:tr>
+              <a:tr h="247650">
+                <a:tc>
+                  <a:txBody>
+                    <a:bodyPr/>
+                    <a:lstStyle/>
+                    <a:p>
+                      <a:r>
+                        <a:rPr sz="1200" b="0" i="0">
+                          <a:solidFill>
+                            <a:srgbClr val="182B49"/>
+                          </a:solidFill>
+                          <a:latin typeface="Helvetica Neue"/>
+                        </a:rPr>
+                        <a:t>t̄t</a:t>
+                      </a:r>
+                    </a:p>
+                  </a:txBody>
+                  <a:tcPr anchor="ctr">
+                    <a:solidFill>
+                      <a:srgbClr val="FFFFFF"/>
+                    </a:solidFill>
+                  </a:tcPr>
+                </a:tc>
+                <a:tc>
+                  <a:txBody>
+                    <a:bodyPr/>
+                    <a:lstStyle/>
+                    <a:p>
+                      <a:r>
+                        <a:rPr sz="1200" b="0" i="0">
+                          <a:solidFill>
+                            <a:srgbClr val="222C3A"/>
+                          </a:solidFill>
+                          <a:latin typeface="Consolas"/>
+                        </a:rPr>
+                        <a:t>2</a:t>
+                      </a:r>
+                    </a:p>
+                  </a:txBody>
+                  <a:tcPr anchor="ctr">
+                    <a:solidFill>
+                      <a:srgbClr val="FFFFFF"/>
+                    </a:solidFill>
+                  </a:tcPr>
+                </a:tc>
+                <a:tc>
+                  <a:txBody>
+                    <a:bodyPr/>
+                    <a:lstStyle/>
+                    <a:p>
+                      <a:r>
+                        <a:rPr sz="1200" b="0" i="0">
+                          <a:solidFill>
+                            <a:srgbClr val="222C3A"/>
+                          </a:solidFill>
+                          <a:latin typeface="Consolas"/>
+                        </a:rPr>
+                        <a:t>1.9×10</a:t>
+                      </a:r>
+                      <a:r>
+                        <a:rPr sz="744" b="0" i="0" baseline="30000">
+                          <a:solidFill>
+                            <a:srgbClr val="222C3A"/>
+                          </a:solidFill>
+                          <a:latin typeface="Consolas"/>
+                        </a:rPr>
+                        <a:t>4</a:t>
+                      </a:r>
+                    </a:p>
+                  </a:txBody>
+                  <a:tcPr anchor="ctr">
+                    <a:solidFill>
+                      <a:srgbClr val="FFFFFF"/>
+                    </a:solidFill>
+                  </a:tcPr>
+                </a:tc>
+                <a:tc>
+                  <a:txBody>
+                    <a:bodyPr/>
+                    <a:lstStyle/>
+                    <a:p>
+                      <a:r>
+                        <a:rPr sz="1200" b="0" i="0">
+                          <a:solidFill>
+                            <a:srgbClr val="222C3A"/>
+                          </a:solidFill>
+                          <a:latin typeface="Consolas"/>
+                        </a:rPr>
+                        <a:t>2</a:t>
+                      </a:r>
+                    </a:p>
+                  </a:txBody>
+                  <a:tcPr anchor="ctr">
+                    <a:solidFill>
+                      <a:srgbClr val="FFFFFF"/>
+                    </a:solidFill>
+                  </a:tcPr>
+                </a:tc>
+              </a:tr>
+              <a:tr h="247650">
+                <a:tc>
+                  <a:txBody>
+                    <a:bodyPr/>
+                    <a:lstStyle/>
+                    <a:p>
+                      <a:r>
+                        <a:rPr sz="1200" b="0" i="0">
+                          <a:solidFill>
+                            <a:srgbClr val="182B49"/>
+                          </a:solidFill>
+                          <a:latin typeface="Helvetica Neue"/>
+                        </a:rPr>
+                        <a:t>tttt</a:t>
+                      </a:r>
+                    </a:p>
+                  </a:txBody>
+                  <a:tcPr anchor="ctr">
+                    <a:solidFill>
+                      <a:srgbClr val="FFFFFF"/>
+                    </a:solidFill>
+                  </a:tcPr>
+                </a:tc>
+                <a:tc>
+                  <a:txBody>
+                    <a:bodyPr/>
+                    <a:lstStyle/>
+                    <a:p>
+                      <a:r>
+                        <a:rPr sz="1200" b="0" i="0">
+                          <a:solidFill>
+                            <a:srgbClr val="222C3A"/>
+                          </a:solidFill>
+                          <a:latin typeface="Consolas"/>
+                        </a:rPr>
+                        <a:t>4</a:t>
+                      </a:r>
+                    </a:p>
+                  </a:txBody>
+                  <a:tcPr anchor="ctr">
+                    <a:solidFill>
+                      <a:srgbClr val="FFFFFF"/>
+                    </a:solidFill>
+                  </a:tcPr>
+                </a:tc>
+                <a:tc>
+                  <a:txBody>
+                    <a:bodyPr/>
+                    <a:lstStyle/>
+                    <a:p>
+                      <a:r>
+                        <a:rPr sz="1200" b="0" i="0">
+                          <a:solidFill>
+                            <a:srgbClr val="222C3A"/>
+                          </a:solidFill>
+                          <a:latin typeface="Consolas"/>
+                        </a:rPr>
+                        <a:t>2.3×10</a:t>
+                      </a:r>
+                      <a:r>
+                        <a:rPr sz="744" b="0" i="0" baseline="30000">
+                          <a:solidFill>
+                            <a:srgbClr val="222C3A"/>
+                          </a:solidFill>
+                          <a:latin typeface="Consolas"/>
+                        </a:rPr>
+                        <a:t>9</a:t>
+                      </a:r>
+                    </a:p>
+                  </a:txBody>
+                  <a:tcPr anchor="ctr">
+                    <a:solidFill>
+                      <a:srgbClr val="FFFFFF"/>
+                    </a:solidFill>
+                  </a:tcPr>
+                </a:tc>
+                <a:tc>
+                  <a:txBody>
+                    <a:bodyPr/>
+                    <a:lstStyle/>
+                    <a:p>
+                      <a:r>
+                        <a:rPr sz="1200" b="0" i="0">
+                          <a:solidFill>
+                            <a:srgbClr val="222C3A"/>
+                          </a:solidFill>
+                          <a:latin typeface="Consolas"/>
+                        </a:rPr>
+                        <a:t>24</a:t>
+                      </a:r>
+                    </a:p>
+                  </a:txBody>
+                  <a:tcPr anchor="ctr">
+                    <a:solidFill>
+                      <a:srgbClr val="FFFFFF"/>
+                    </a:solidFill>
+                  </a:tcPr>
+                </a:tc>
+              </a:tr>
+              <a:tr h="247650">
+                <a:tc>
+                  <a:txBody>
+                    <a:bodyPr/>
+                    <a:lstStyle/>
+                    <a:p>
+                      <a:r>
+                        <a:rPr sz="1200" b="0" i="0">
+                          <a:solidFill>
+                            <a:srgbClr val="182B49"/>
+                          </a:solidFill>
+                          <a:latin typeface="Helvetica Neue"/>
+                        </a:rPr>
+                        <a:t>t̄tt̄tt̄t</a:t>
+                      </a:r>
+                    </a:p>
+                  </a:txBody>
+                  <a:tcPr anchor="ctr">
+                    <a:solidFill>
+                      <a:srgbClr val="FFFFFF"/>
+                    </a:solidFill>
+                  </a:tcPr>
+                </a:tc>
+                <a:tc>
+                  <a:txBody>
+                    <a:bodyPr/>
+                    <a:lstStyle/>
+                    <a:p>
+                      <a:r>
+                        <a:rPr sz="1200" b="0" i="0">
+                          <a:solidFill>
+                            <a:srgbClr val="222C3A"/>
+                          </a:solidFill>
+                          <a:latin typeface="Consolas"/>
+                        </a:rPr>
+                        <a:t>6</a:t>
+                      </a:r>
+                    </a:p>
+                  </a:txBody>
+                  <a:tcPr anchor="ctr">
+                    <a:solidFill>
+                      <a:srgbClr val="FFFFFF"/>
+                    </a:solidFill>
+                  </a:tcPr>
+                </a:tc>
+                <a:tc>
+                  <a:txBody>
+                    <a:bodyPr/>
+                    <a:lstStyle/>
+                    <a:p>
+                      <a:r>
+                        <a:rPr sz="1200" b="0" i="0">
+                          <a:solidFill>
+                            <a:srgbClr val="222C3A"/>
+                          </a:solidFill>
+                          <a:latin typeface="Consolas"/>
+                        </a:rPr>
+                        <a:t>1.0×10</a:t>
+                      </a:r>
+                      <a:r>
+                        <a:rPr sz="744" b="0" i="0" baseline="30000">
+                          <a:solidFill>
+                            <a:srgbClr val="222C3A"/>
+                          </a:solidFill>
+                          <a:latin typeface="Consolas"/>
+                        </a:rPr>
+                        <a:t>15</a:t>
+                      </a:r>
+                    </a:p>
+                  </a:txBody>
+                  <a:tcPr anchor="ctr">
+                    <a:solidFill>
+                      <a:srgbClr val="FFFFFF"/>
+                    </a:solidFill>
+                  </a:tcPr>
+                </a:tc>
+                <a:tc>
+                  <a:txBody>
+                    <a:bodyPr/>
+                    <a:lstStyle/>
+                    <a:p>
+                      <a:r>
+                        <a:rPr sz="1200" b="0" i="0">
+                          <a:solidFill>
+                            <a:srgbClr val="222C3A"/>
+                          </a:solidFill>
+                          <a:latin typeface="Consolas"/>
+                        </a:rPr>
+                        <a:t>720</a:t>
+                      </a:r>
+                    </a:p>
+                  </a:txBody>
+                  <a:tcPr anchor="ctr">
+                    <a:solidFill>
+                      <a:srgbClr val="FFFFFF"/>
+                    </a:solidFill>
+                  </a:tcPr>
+                </a:tc>
+              </a:tr>
+            </a:tbl>
+          </a:graphicData>
+        </a:graphic>
+      </p:graphicFrame>
     </p:spTree>
   </p:cSld>
   <p:clrMapOvr>

</xml_diff>